<commit_message>
docs: update the introduction deck and add a PDF export
</commit_message>
<xml_diff>
--- a/doc/ja/introduction.pptx
+++ b/doc/ja/introduction.pptx
@@ -1499,7 +1499,7 @@
           <a:lstStyle/>
           <a:p>
             <a:fld id="{5BCAD085-E8A6-8845-BD4E-CB4CCA059FC4}" type="datetimeFigureOut">
-              <a:t>2026/9/1</a:t>
+              <a:t>2026/9/2</a:t>
             </a:fld>
             <a:endParaRPr/>
           </a:p>
@@ -1694,7 +1694,7 @@
           <a:lstStyle/>
           <a:p>
             <a:fld id="{5BCAD085-E8A6-8845-BD4E-CB4CCA059FC4}" type="datetimeFigureOut">
-              <a:t>2026/9/1</a:t>
+              <a:t>2026/9/2</a:t>
             </a:fld>
             <a:endParaRPr/>
           </a:p>
@@ -1899,7 +1899,7 @@
           <a:lstStyle/>
           <a:p>
             <a:fld id="{5BCAD085-E8A6-8845-BD4E-CB4CCA059FC4}" type="datetimeFigureOut">
-              <a:t>2026/9/1</a:t>
+              <a:t>2026/9/2</a:t>
             </a:fld>
             <a:endParaRPr/>
           </a:p>
@@ -2094,7 +2094,7 @@
           <a:lstStyle/>
           <a:p>
             <a:fld id="{5BCAD085-E8A6-8845-BD4E-CB4CCA059FC4}" type="datetimeFigureOut">
-              <a:t>2026/9/1</a:t>
+              <a:t>2026/9/2</a:t>
             </a:fld>
             <a:endParaRPr/>
           </a:p>
@@ -2363,7 +2363,7 @@
           <a:lstStyle/>
           <a:p>
             <a:fld id="{5BCAD085-E8A6-8845-BD4E-CB4CCA059FC4}" type="datetimeFigureOut">
-              <a:t>2026/9/1</a:t>
+              <a:t>2026/9/2</a:t>
             </a:fld>
             <a:endParaRPr/>
           </a:p>
@@ -2704,7 +2704,7 @@
           <a:lstStyle/>
           <a:p>
             <a:fld id="{5BCAD085-E8A6-8845-BD4E-CB4CCA059FC4}" type="datetimeFigureOut">
-              <a:t>2026/9/1</a:t>
+              <a:t>2026/9/2</a:t>
             </a:fld>
             <a:endParaRPr/>
           </a:p>
@@ -3194,7 +3194,7 @@
           <a:lstStyle/>
           <a:p>
             <a:fld id="{5BCAD085-E8A6-8845-BD4E-CB4CCA059FC4}" type="datetimeFigureOut">
-              <a:t>2026/9/1</a:t>
+              <a:t>2026/9/2</a:t>
             </a:fld>
             <a:endParaRPr/>
           </a:p>
@@ -3327,7 +3327,7 @@
           <a:lstStyle/>
           <a:p>
             <a:fld id="{5BCAD085-E8A6-8845-BD4E-CB4CCA059FC4}" type="datetimeFigureOut">
-              <a:t>2026/9/1</a:t>
+              <a:t>2026/9/2</a:t>
             </a:fld>
             <a:endParaRPr/>
           </a:p>
@@ -3433,7 +3433,7 @@
           <a:lstStyle/>
           <a:p>
             <a:fld id="{5BCAD085-E8A6-8845-BD4E-CB4CCA059FC4}" type="datetimeFigureOut">
-              <a:t>2026/9/1</a:t>
+              <a:t>2026/9/2</a:t>
             </a:fld>
             <a:endParaRPr/>
           </a:p>
@@ -3752,7 +3752,7 @@
           <a:lstStyle/>
           <a:p>
             <a:fld id="{5BCAD085-E8A6-8845-BD4E-CB4CCA059FC4}" type="datetimeFigureOut">
-              <a:t>2026/9/1</a:t>
+              <a:t>2026/9/2</a:t>
             </a:fld>
             <a:endParaRPr/>
           </a:p>
@@ -4034,7 +4034,7 @@
           <a:lstStyle/>
           <a:p>
             <a:fld id="{5BCAD085-E8A6-8845-BD4E-CB4CCA059FC4}" type="datetimeFigureOut">
-              <a:t>2026/9/1</a:t>
+              <a:t>2026/9/2</a:t>
             </a:fld>
             <a:endParaRPr/>
           </a:p>
@@ -4273,7 +4273,7 @@
           </a:lstStyle>
           <a:p>
             <a:fld id="{5BCAD085-E8A6-8845-BD4E-CB4CCA059FC4}" type="datetimeFigureOut">
-              <a:t>2026/9/1</a:t>
+              <a:t>2026/9/2</a:t>
             </a:fld>
             <a:endParaRPr/>
           </a:p>
@@ -8025,7 +8025,7 @@
         <p:spPr>
           <a:xfrm>
             <a:off x="876300" y="2238375"/>
-            <a:ext cx="1123950" cy="323850"/>
+            <a:ext cx="1241920" cy="323850"/>
           </a:xfrm>
           <a:prstGeom prst="roundRect">
             <a:avLst>
@@ -8065,7 +8065,7 @@
         <p:spPr>
           <a:xfrm>
             <a:off x="971550" y="2247900"/>
-            <a:ext cx="933450" cy="295275"/>
+            <a:ext cx="1104900" cy="295275"/>
           </a:xfrm>
           <a:prstGeom prst="rect">
             <a:avLst/>
@@ -8088,13 +8088,26 @@
               </a:defRPr>
             </a:pPr>
             <a:r>
-              <a:rPr sz="1275" b="1">
+              <a:rPr sz="1275" b="1" dirty="0">
                 <a:solidFill>
                   <a:srgbClr val="2F80ED"/>
                 </a:solidFill>
               </a:rPr>
-              <a:t>01 変化</a:t>
-            </a:r>
+              <a:t>01 </a:t>
+            </a:r>
+            <a:r>
+              <a:rPr lang="ja-JP" altLang="en-US" sz="1275" b="1" dirty="0">
+                <a:solidFill>
+                  <a:srgbClr val="2F80ED"/>
+                </a:solidFill>
+              </a:rPr>
+              <a:t>状況変化</a:t>
+            </a:r>
+            <a:endParaRPr sz="1275" b="1" dirty="0">
+              <a:solidFill>
+                <a:srgbClr val="2F80ED"/>
+              </a:solidFill>
+            </a:endParaRPr>
           </a:p>
         </p:txBody>
       </p:sp>
@@ -8349,13 +8362,26 @@
               </a:defRPr>
             </a:pPr>
             <a:r>
-              <a:rPr sz="1275" b="1">
+              <a:rPr sz="1275" b="1" dirty="0">
                 <a:solidFill>
                   <a:srgbClr val="E76F51"/>
                 </a:solidFill>
               </a:rPr>
-              <a:t>02 ギャップ</a:t>
-            </a:r>
+              <a:t>02 </a:t>
+            </a:r>
+            <a:r>
+              <a:rPr lang="ja-JP" altLang="en-US" sz="1275" b="1" dirty="0">
+                <a:solidFill>
+                  <a:srgbClr val="E76F51"/>
+                </a:solidFill>
+              </a:rPr>
+              <a:t>課題</a:t>
+            </a:r>
+            <a:endParaRPr sz="1275" b="1" dirty="0">
+              <a:solidFill>
+                <a:srgbClr val="E76F51"/>
+              </a:solidFill>
+            </a:endParaRPr>
           </a:p>
         </p:txBody>
       </p:sp>
@@ -8627,13 +8653,34 @@
               </a:defRPr>
             </a:pPr>
             <a:r>
-              <a:rPr sz="1275" b="1">
+              <a:rPr sz="1275" b="1" dirty="0">
                 <a:solidFill>
                   <a:srgbClr val="0A7C62"/>
                 </a:solidFill>
               </a:rPr>
-              <a:t>03 解決</a:t>
-            </a:r>
+              <a:t>03 </a:t>
+            </a:r>
+            <a:r>
+              <a:rPr sz="1275" b="1" dirty="0" err="1">
+                <a:solidFill>
+                  <a:srgbClr val="0A7C62"/>
+                </a:solidFill>
+              </a:rPr>
+              <a:t>解決</a:t>
+            </a:r>
+            <a:r>
+              <a:rPr lang="ja-JP" altLang="en-US" sz="1275" b="1" dirty="0">
+                <a:solidFill>
+                  <a:srgbClr val="0A7C62"/>
+                </a:solidFill>
+              </a:rPr>
+              <a:t>策</a:t>
+            </a:r>
+            <a:endParaRPr sz="1275" b="1" dirty="0">
+              <a:solidFill>
+                <a:srgbClr val="0A7C62"/>
+              </a:solidFill>
+            </a:endParaRPr>
           </a:p>
         </p:txBody>
       </p:sp>
@@ -8677,13 +8724,18 @@
               </a:defRPr>
             </a:pPr>
             <a:r>
-              <a:rPr sz="2325" b="1">
+              <a:rPr sz="2325" b="1" dirty="0" err="1">
                 <a:solidFill>
                   <a:srgbClr val="10251F"/>
                 </a:solidFill>
               </a:rPr>
               <a:t>RustをWasm化し</a:t>
             </a:r>
+            <a:endParaRPr sz="2325" b="1" dirty="0">
+              <a:solidFill>
+                <a:srgbClr val="10251F"/>
+              </a:solidFill>
+            </a:endParaRPr>
           </a:p>
           <a:p>
             <a:pPr algn="l">
@@ -8694,13 +8746,18 @@
               </a:defRPr>
             </a:pPr>
             <a:r>
-              <a:rPr sz="2325" b="1">
+              <a:rPr sz="2325" b="1" dirty="0" err="1">
                 <a:solidFill>
                   <a:srgbClr val="10251F"/>
                 </a:solidFill>
               </a:rPr>
               <a:t>Javaバイトコードへ</a:t>
             </a:r>
+            <a:endParaRPr sz="2325" b="1" dirty="0">
+              <a:solidFill>
+                <a:srgbClr val="10251F"/>
+              </a:solidFill>
+            </a:endParaRPr>
           </a:p>
         </p:txBody>
       </p:sp>
@@ -8901,13 +8958,18 @@
               </a:defRPr>
             </a:pPr>
             <a:r>
-              <a:rPr sz="1950" b="1">
+              <a:rPr sz="1950" b="1" dirty="0" err="1">
                 <a:solidFill>
                   <a:srgbClr val="FFFFFF"/>
                 </a:solidFill>
               </a:rPr>
-              <a:t>ピーク速度より安全性と可搬性を重視する用途で、jxl-javaは有力な選択肢になる</a:t>
-            </a:r>
+              <a:t>ピーク速度より安全性と可搬性を重視する用途で、jxl-javaは有力な選択肢</a:t>
+            </a:r>
+            <a:endParaRPr sz="1950" b="1" dirty="0">
+              <a:solidFill>
+                <a:srgbClr val="FFFFFF"/>
+              </a:solidFill>
+            </a:endParaRPr>
           </a:p>
         </p:txBody>
       </p:sp>
@@ -9180,14 +9242,6 @@
               <a:t>く</a:t>
             </a:r>
             <a:r>
-              <a:rPr sz="1650" b="0" dirty="0">
-                <a:solidFill>
-                  <a:srgbClr val="556B64"/>
-                </a:solidFill>
-              </a:rPr>
-              <a:t>、</a:t>
-            </a:r>
-            <a:r>
               <a:rPr sz="1650" b="0" dirty="0" err="1">
                 <a:solidFill>
                   <a:srgbClr val="556B64"/>
@@ -10886,7 +10940,7 @@
                   <a:srgbClr val="10251F"/>
                 </a:solidFill>
               </a:rPr>
-              <a:t>JNI経由では、画像処理のリスクが</a:t>
+              <a:t>JNI経由では画像処理のリスクが</a:t>
             </a:r>
             <a:r>
               <a:rPr lang="ja-JP" altLang="en-US" sz="3600" b="1" dirty="0">
@@ -11455,8 +11509,8 @@
         </p:nvSpPr>
         <p:spPr>
           <a:xfrm>
-            <a:off x="5095875" y="2790825"/>
-            <a:ext cx="1190625" cy="838200"/>
+            <a:off x="4946053" y="2819400"/>
+            <a:ext cx="1518844" cy="838200"/>
           </a:xfrm>
           <a:prstGeom prst="rect">
             <a:avLst/>
@@ -11901,13 +11955,18 @@
               </a:defRPr>
             </a:pPr>
             <a:r>
-              <a:rPr sz="1500" b="1">
+              <a:rPr sz="1500" b="1" dirty="0" err="1">
                 <a:solidFill>
                   <a:srgbClr val="0A7C62"/>
                 </a:solidFill>
               </a:rPr>
               <a:t>異常はIOExceptionとして隔離</a:t>
             </a:r>
+            <a:endParaRPr sz="1500" b="1" dirty="0">
+              <a:solidFill>
+                <a:srgbClr val="0A7C62"/>
+              </a:solidFill>
+            </a:endParaRPr>
           </a:p>
         </p:txBody>
       </p:sp>
@@ -11927,7 +11986,7 @@
         </p:nvSpPr>
         <p:spPr>
           <a:xfrm>
-            <a:off x="7505700" y="2773610"/>
+            <a:off x="7505700" y="2677138"/>
             <a:ext cx="666750" cy="266700"/>
           </a:xfrm>
           <a:prstGeom prst="rect">
@@ -11951,7 +12010,7 @@
               </a:defRPr>
             </a:pPr>
             <a:r>
-              <a:rPr sz="1350" b="1">
+              <a:rPr sz="1350" b="1" dirty="0">
                 <a:solidFill>
                   <a:srgbClr val="0A7C62"/>
                 </a:solidFill>

</xml_diff>